<commit_message>
LA-2 report and deck: remove the AI co-author line from the Git section
Co-Authored-By: Claude Opus 5.5 <noreply@anthropic.com>
</commit_message>
<xml_diff>
--- a/deliverables/LA2/LA2_PromptOpt.pptx
+++ b/deliverables/LA2/LA2_PromptOpt.pptx
@@ -124,13 +124,13 @@
   <p:extLst>
     <p:ext uri="{521415D9-36F7-43E2-AB2F-B90AF26B5E84}">
       <p14:sectionLst xmlns:p14="http://schemas.microsoft.com/office/powerpoint/2010/main">
-        <p14:section name="Opening" id="{09b05d56-bb7d-9940-5a22-57edc00f212a}">
+        <p14:section name="Opening" id="{9de1667a-8f80-d669-0a3b-9abb1382fb3f}">
           <p14:sldIdLst>
             <p14:sldId id="256"/>
             <p14:sldId id="257"/>
           </p14:sldIdLst>
         </p14:section>
-        <p14:section name="Core modules" id="{ef330e86-c31e-12f5-4a0c-c3b2383e096e}">
+        <p14:section name="Core modules" id="{8840bdc6-3834-5797-fc0e-62e829ba60c3}">
           <p14:sldIdLst>
             <p14:sldId id="258"/>
             <p14:sldId id="259"/>
@@ -139,26 +139,26 @@
             <p14:sldId id="262"/>
           </p14:sldIdLst>
         </p14:section>
-        <p14:section name="Transactions" id="{5cb29201-64af-e485-2fc5-373427873866}">
+        <p14:section name="Transactions" id="{ad5a7a38-d15f-aa04-55a8-1f56928cb77e}">
           <p14:sldIdLst>
             <p14:sldId id="263"/>
             <p14:sldId id="264"/>
           </p14:sldIdLst>
         </p14:section>
-        <p14:section name="Testing" id="{2f1f28c7-7c87-d42e-a083-d0162a92e03a}">
+        <p14:section name="Testing" id="{7cdd73ce-be24-91a7-675e-ad7e52615482}">
           <p14:sldIdLst>
             <p14:sldId id="265"/>
             <p14:sldId id="266"/>
             <p14:sldId id="267"/>
           </p14:sldIdLst>
         </p14:section>
-        <p14:section name="Results" id="{f7dd6208-89fd-7f40-6fb3-5cb03fffad50}">
+        <p14:section name="Results" id="{3ae0c79c-38d5-7cd6-b613-91e00e845bea}">
           <p14:sldIdLst>
             <p14:sldId id="268"/>
             <p14:sldId id="269"/>
           </p14:sldIdLst>
         </p14:section>
-        <p14:section name="Process" id="{626b6318-43cb-4402-4ed1-50f3285add9c}">
+        <p14:section name="Process" id="{97346b3e-cc59-367c-9aad-74f722500c77}">
           <p14:sldIdLst>
             <p14:sldId id="270"/>
             <p14:sldId id="271"/>
@@ -2193,7 +2193,7 @@
           <a:p>
             <a:r>
               <a:rPr lang="en-US" dirty="0"/>
-              <a:t>Presenter: Nirzara. All numbers are from git. 92 commits between 13 August and 10 October, on three branches: main, ui-v2 and correctness-suite. Tags were our evaluation checkpoints: frozen-for-test marks the code for the final numbers, final-for-test the one-time test run, v1.0 the release with the Stage C adapter attached. We did not use GitHub Issues or Projects; we tracked work with the roadmap and phase tables in the repository and with tags. Many commits were written with an AI coding assistant credited as co-author.</a:t>
+              <a:t>Presenter: Nirzara. All numbers are from git. 92 commits between 13 August and 10 October, on three branches: main, ui-v2 and correctness-suite. Tags were our evaluation checkpoints: frozen-for-test marks the code for the final numbers, final-for-test the one-time test run, v1.0 the release with the Stage C adapter attached. We did not use GitHub Issues or Projects; we tracked work with the roadmap and phase tables in the repository and with tags.</a:t>
             </a:r>
             <a:endParaRPr lang="en-US" dirty="0"/>
           </a:p>

</xml_diff>

<commit_message>
LA-2 report and deck: GitHub screenshot cropped to the repository header and file list
Co-Authored-By: Claude Opus 5.5 <noreply@anthropic.com>
</commit_message>
<xml_diff>
--- a/deliverables/LA2/LA2_PromptOpt.pptx
+++ b/deliverables/LA2/LA2_PromptOpt.pptx
@@ -124,13 +124,13 @@
   <p:extLst>
     <p:ext uri="{521415D9-36F7-43E2-AB2F-B90AF26B5E84}">
       <p14:sectionLst xmlns:p14="http://schemas.microsoft.com/office/powerpoint/2010/main">
-        <p14:section name="Opening" id="{9de1667a-8f80-d669-0a3b-9abb1382fb3f}">
+        <p14:section name="Opening" id="{3ac47cf8-0d51-a53d-4006-29707b7c7bf6}">
           <p14:sldIdLst>
             <p14:sldId id="256"/>
             <p14:sldId id="257"/>
           </p14:sldIdLst>
         </p14:section>
-        <p14:section name="Core modules" id="{8840bdc6-3834-5797-fc0e-62e829ba60c3}">
+        <p14:section name="Core modules" id="{5742b9ed-5d85-7b33-7184-acd5cf296e05}">
           <p14:sldIdLst>
             <p14:sldId id="258"/>
             <p14:sldId id="259"/>
@@ -139,26 +139,26 @@
             <p14:sldId id="262"/>
           </p14:sldIdLst>
         </p14:section>
-        <p14:section name="Transactions" id="{ad5a7a38-d15f-aa04-55a8-1f56928cb77e}">
+        <p14:section name="Transactions" id="{5ebef532-979b-ddf9-f10e-ec378a9dcbd3}">
           <p14:sldIdLst>
             <p14:sldId id="263"/>
             <p14:sldId id="264"/>
           </p14:sldIdLst>
         </p14:section>
-        <p14:section name="Testing" id="{7cdd73ce-be24-91a7-675e-ad7e52615482}">
+        <p14:section name="Testing" id="{dda9936b-f043-6537-a3db-39769bf3763f}">
           <p14:sldIdLst>
             <p14:sldId id="265"/>
             <p14:sldId id="266"/>
             <p14:sldId id="267"/>
           </p14:sldIdLst>
         </p14:section>
-        <p14:section name="Results" id="{3ae0c79c-38d5-7cd6-b613-91e00e845bea}">
+        <p14:section name="Results" id="{14e1cdc1-11ce-87bc-4164-5fe61c0ce92e}">
           <p14:sldIdLst>
             <p14:sldId id="268"/>
             <p14:sldId id="269"/>
           </p14:sldIdLst>
         </p14:section>
-        <p14:section name="Process" id="{97346b3e-cc59-367c-9aad-74f722500c77}">
+        <p14:section name="Process" id="{3347cdd0-d544-8cff-ddfe-6174abc167b6}">
           <p14:sldIdLst>
             <p14:sldId id="270"/>
             <p14:sldId id="271"/>
@@ -9246,8 +9246,8 @@
         </p:blipFill>
         <p:spPr>
           <a:xfrm>
-            <a:off x="457200" y="1188720"/>
-            <a:ext cx="5669280" cy="3986213"/>
+            <a:off x="457200" y="1371600"/>
+            <a:ext cx="5669280" cy="3142085"/>
           </a:xfrm>
           <a:prstGeom prst="rect">
             <a:avLst/>
@@ -9735,7 +9735,7 @@
         </p:nvSpPr>
         <p:spPr>
           <a:xfrm>
-            <a:off x="457200" y="5303520"/>
+            <a:off x="457200" y="4663440"/>
             <a:ext cx="5669280" cy="365760"/>
           </a:xfrm>
           <a:prstGeom prst="rect">

</xml_diff>

<commit_message>
LA-2 deck: wider title-slide text boxes and integer chart labels (clean Canva import)
Co-Authored-By: Claude Opus 5.5 <noreply@anthropic.com>
</commit_message>
<xml_diff>
--- a/deliverables/LA2/LA2_PromptOpt.pptx
+++ b/deliverables/LA2/LA2_PromptOpt.pptx
@@ -331,6 +331,7 @@
           </c:val>
         </c:ser>
         <c:dLbls>
+          <c:numFmt formatCode="0" sourceLinked="0"/>
           <c:txPr>
             <a:bodyPr/>
             <a:lstStyle/>
@@ -590,6 +591,7 @@
           </c:val>
         </c:ser>
         <c:dLbls>
+          <c:numFmt formatCode="0" sourceLinked="0"/>
           <c:txPr>
             <a:bodyPr/>
             <a:lstStyle/>
@@ -875,6 +877,7 @@
           </c:val>
         </c:ser>
         <c:dLbls>
+          <c:numFmt formatCode="0" sourceLinked="0"/>
           <c:txPr>
             <a:bodyPr/>
             <a:lstStyle/>
@@ -5933,8 +5936,8 @@
         </p:nvSpPr>
         <p:spPr>
           <a:xfrm rot="0">
-            <a:off x="5978301" y="4214087"/>
-            <a:ext cx="6331398" cy="2118258"/>
+            <a:off x="5029200" y="4214087"/>
+            <a:ext cx="8229600" cy="2118258"/>
           </a:xfrm>
           <a:prstGeom prst="rect">
             <a:avLst/>
@@ -6012,8 +6015,8 @@
         </p:nvSpPr>
         <p:spPr>
           <a:xfrm rot="0">
-            <a:off x="7219442" y="8728282"/>
-            <a:ext cx="3827743" cy="986155"/>
+            <a:off x="6390113" y="8728282"/>
+            <a:ext cx="5486400" cy="986155"/>
           </a:xfrm>
           <a:prstGeom prst="rect">
             <a:avLst/>
@@ -6314,8 +6317,8 @@
         </p:nvSpPr>
         <p:spPr>
           <a:xfrm rot="0">
-            <a:off x="4417442" y="2271291"/>
-            <a:ext cx="9453116" cy="704971"/>
+            <a:off x="2971800" y="2271291"/>
+            <a:ext cx="12344400" cy="704971"/>
           </a:xfrm>
           <a:prstGeom prst="rect">
             <a:avLst/>
@@ -6358,8 +6361,8 @@
         </p:nvSpPr>
         <p:spPr>
           <a:xfrm rot="0">
-            <a:off x="4104113" y="3031507"/>
-            <a:ext cx="10058400" cy="455365"/>
+            <a:off x="3875513" y="3031507"/>
+            <a:ext cx="10515600" cy="455365"/>
           </a:xfrm>
           <a:prstGeom prst="rect">
             <a:avLst/>
@@ -6470,8 +6473,8 @@
         </p:nvSpPr>
         <p:spPr>
           <a:xfrm rot="0">
-            <a:off x="8652272" y="3855242"/>
-            <a:ext cx="983456" cy="339795"/>
+            <a:off x="7772400" y="3855242"/>
+            <a:ext cx="2743200" cy="339795"/>
           </a:xfrm>
           <a:prstGeom prst="rect">
             <a:avLst/>

</xml_diff>